<commit_message>
se agrego la url del repo
</commit_message>
<xml_diff>
--- a/documentacion/Presentación Corte 2 - Inventario.pptx
+++ b/documentacion/Presentación Corte 2 - Inventario.pptx
@@ -7594,7 +7594,7 @@
         </p:spPr>
         <p:txBody>
           <a:bodyPr wrap="square" lIns="0" tIns="0" rIns="0" bIns="0" rtlCol="0" anchor="t">
-            <a:normAutofit/>
+            <a:normAutofit fontScale="85000" lnSpcReduction="10000"/>
           </a:bodyPr>
           <a:lstStyle/>
           <a:p>
@@ -7605,17 +7605,13 @@
               <a:buNone/>
             </a:pPr>
             <a:r>
-              <a:rPr lang="en-US" sz="2000" b="1" dirty="0">
-                <a:solidFill>
-                  <a:srgbClr val="F6F5F1"/>
-                </a:solidFill>
-                <a:latin typeface="DM Sans" pitchFamily="34" charset="0"/>
-                <a:ea typeface="DM Sans" pitchFamily="34" charset="-122"/>
-                <a:cs typeface="DM Sans" pitchFamily="34" charset="-120"/>
-              </a:rPr>
-              <a:t>[COMPLETAR: enlace al repositorio]</a:t>
-            </a:r>
-            <a:endParaRPr lang="en-US" sz="2000" dirty="0"/>
+              <a:rPr lang="en-US" sz="2000" dirty="0">
+                <a:solidFill>
+                  <a:schemeClr val="bg1"/>
+                </a:solidFill>
+              </a:rPr>
+              <a:t>https://github.com/michaelEAM/n8n-inventario-alertas-reposicion?utm_source=chatgpt.com</a:t>
+            </a:r>
           </a:p>
         </p:txBody>
       </p:sp>

</xml_diff>